<commit_message>
Add Education->T edge to the supplementary ordering slide per instructor feedback
</commit_message>
<xml_diff>
--- a/dag/DAG_Editable.pptx
+++ b/dag/DAG_Editable.pptx
@@ -6283,14 +6283,145 @@
       </p:cxnSp>
       <p:sp>
         <p:nvSpPr>
-          <p:cNvPr id="21" name="TextBox 20"/>
+          <p:cNvPr id="21" name="Rounded Rectangle 20"/>
+          <p:cNvSpPr/>
+          <p:nvPr/>
+        </p:nvSpPr>
+        <p:spPr>
+          <a:xfrm>
+            <a:off x="17922240" y="8366760"/>
+            <a:ext cx="2926080" cy="1234440"/>
+          </a:xfrm>
+          <a:prstGeom prst="roundRect">
+            <a:avLst/>
+          </a:prstGeom>
+          <a:solidFill>
+            <a:srgbClr val="FDE3D0"/>
+          </a:solidFill>
+          <a:ln w="25400">
+            <a:solidFill>
+              <a:srgbClr val="C1611A"/>
+            </a:solidFill>
+          </a:ln>
+          <a:effectLst/>
+        </p:spPr>
+        <p:style>
+          <a:lnRef idx="1">
+            <a:schemeClr val="accent1"/>
+          </a:lnRef>
+          <a:fillRef idx="3">
+            <a:schemeClr val="accent1"/>
+          </a:fillRef>
+          <a:effectRef idx="2">
+            <a:schemeClr val="accent1"/>
+          </a:effectRef>
+          <a:fontRef idx="minor">
+            <a:schemeClr val="lt1"/>
+          </a:fontRef>
+        </p:style>
+        <p:txBody>
+          <a:bodyPr rtlCol="0" anchor="t" wrap="square" lIns="54864" rIns="54864" tIns="36576" bIns="36576"/>
+          <a:lstStyle/>
+          <a:p>
+            <a:pPr algn="ctr">
+              <a:lnSpc>
+                <a:spcPct val="100000"/>
+              </a:lnSpc>
+            </a:pPr>
+            <a:r>
+              <a:rPr sz="1300" b="1">
+                <a:solidFill>
+                  <a:srgbClr val="C1611A"/>
+                </a:solidFill>
+                <a:latin typeface="Calibri"/>
+              </a:rPr>
+              <a:t>Maternal smoking</a:t>
+            </a:r>
+          </a:p>
+          <a:p>
+            <a:pPr algn="ctr">
+              <a:lnSpc>
+                <a:spcPct val="100000"/>
+              </a:lnSpc>
+            </a:pPr>
+            <a:r>
+              <a:rPr sz="1300" b="1">
+                <a:solidFill>
+                  <a:srgbClr val="C1611A"/>
+                </a:solidFill>
+                <a:latin typeface="Calibri"/>
+              </a:rPr>
+              <a:t>during pregnancy</a:t>
+            </a:r>
+          </a:p>
+          <a:p>
+            <a:pPr algn="ctr">
+              <a:lnSpc>
+                <a:spcPct val="100000"/>
+              </a:lnSpc>
+            </a:pPr>
+            <a:r>
+              <a:rPr sz="1300" b="1">
+                <a:solidFill>
+                  <a:srgbClr val="C1611A"/>
+                </a:solidFill>
+                <a:latin typeface="Calibri"/>
+              </a:rPr>
+              <a:t>(exposure, T)</a:t>
+            </a:r>
+          </a:p>
+        </p:txBody>
+      </p:sp>
+      <p:cxnSp>
+        <p:nvCxnSpPr>
+          <p:cNvPr id="22" name="Connector 21"/>
+          <p:cNvCxnSpPr>
+            <a:stCxn id="5" idx="2"/>
+            <a:endCxn id="21" idx="3"/>
+          </p:cNvCxnSpPr>
+          <p:nvPr/>
+        </p:nvCxnSpPr>
+        <p:spPr>
+          <a:xfrm>
+            <a:off x="4937759" y="3703320"/>
+            <a:ext cx="15910561" cy="5280660"/>
+          </a:xfrm>
+          <a:prstGeom prst="bentConnector3">
+            <a:avLst/>
+          </a:prstGeom>
+          <a:ln w="34925">
+            <a:solidFill>
+              <a:srgbClr val="C1611A"/>
+            </a:solidFill>
+            <a:tailEnd type="triangle" w="med" len="med"/>
+          </a:ln>
+          <a:effectLst/>
+        </p:spPr>
+        <p:style>
+          <a:lnRef idx="2">
+            <a:schemeClr val="accent1"/>
+          </a:lnRef>
+          <a:fillRef idx="0">
+            <a:schemeClr val="accent1"/>
+          </a:fillRef>
+          <a:effectRef idx="1">
+            <a:schemeClr val="accent1"/>
+          </a:effectRef>
+          <a:fontRef idx="minor">
+            <a:schemeClr val="tx1"/>
+          </a:fontRef>
+        </p:style>
+      </p:cxnSp>
+      <p:sp>
+        <p:nvSpPr>
+          <p:cNvPr id="23" name="TextBox 22"/>
           <p:cNvSpPr txBox="1"/>
           <p:nvPr/>
         </p:nvSpPr>
         <p:spPr>
           <a:xfrm>
-            <a:off x="548640" y="7955279"/>
-            <a:ext cx="22677120" cy="2011680"/>
+            <a:off x="548640" y="9784080"/>
+            <a:ext cx="22677120" cy="1371600"/>
           </a:xfrm>
           <a:prstGeom prst="rect">
             <a:avLst/>
@@ -6305,13 +6436,14 @@
           <a:p>
             <a:pPr algn="l"/>
             <a:r>
-              <a:rPr sz="1300" i="1">
+              <a:rPr sz="1250" i="1">
                 <a:solidFill>
                   <a:srgbClr val="555555"/>
                 </a:solidFill>
                 <a:latin typeface="Calibri"/>
               </a:rPr>
-              <a:t>Note. These steel-blue dashed arrows reflect an assumed temporal / conceptual ordering standard in the perinatal-epidemiology literature (e.g., sociodemographic factors treated as upstream of clinical risk factors) — they are NOT associations estimated from this dataset, and this diagram is not needed to justify the adjustment set. Why: every confounder here is still a direct parent of both T and Y (previous slide), so conditioning on each one individually blocks every path that passes through it, including any longer indirect path that runs through this ordering (a standard d-separation result: conditioning on a non-collider blocks every path through that node). No separate accounting of these indirect paths is required.</a:t>
+              <a:t>Note. These steel-blue dashed arrows reflect an assumed temporal / conceptual ordering standard in the perinatal-epidemiology literature (e.g., sociodemographic factors treated as upstream of clinical risk factors) — they are NOT associations estimated from this dataset, and this diagram is not needed to justify the adjustment set. Why: every confounder here is still a direct parent of both T and Y (previous slide), so conditioning on each one individually blocks every path that passes through it, including any longer indirect path that runs through this ordering (a standard d-separation result: conditioning on a non-collider blocks every path through that node). No separate accounting of these indirect paths is required.
+The solid orange arrow (Education → T) is the one edge into exposure drawn on this slide, shown here deliberately per Dr. Ghosh's feedback: education is the confounder whose edge into smoking is most directly defended in the proposal text, and showing it alongside the assumed ordering makes clear that this diagram's edges are not purely among confounders — one of them terminates in exposure itself. It does not add a 12th path: T ← Education → Y is already path (2) on slide 1.</a:t>
             </a:r>
           </a:p>
         </p:txBody>

</xml_diff>

<commit_message>
Rewrite proposal in professional voice; cite poster's limitation to justify method choice; fix DAG connector routing
</commit_message>
<xml_diff>
--- a/dag/DAG_Editable.pptx
+++ b/dag/DAG_Editable.pptx
@@ -3119,7 +3119,7 @@
                 </a:solidFill>
                 <a:latin typeface="Calibri"/>
               </a:rPr>
-              <a:t>Identification DAG — 10 Backdoor Paths + 1 Causal Path (Maternal Smoking → Preterm Birth)</a:t>
+              <a:t>Identification DAG: 10 Backdoor Paths + 1 Causal Path (Maternal Smoking → Preterm Birth)</a:t>
             </a:r>
           </a:p>
         </p:txBody>
@@ -4897,7 +4897,7 @@
                 </a:solidFill>
                 <a:latin typeface="Calibri"/>
               </a:rPr>
-              <a:t>Paths in this diagram — 11 total, all blocked or estimated once the propensity-score adjustment is applied:
+              <a:t>Paths in this diagram: 11 total, all blocked or estimated once the propensity-score adjustment is applied.
 •  1 causal path:  T → Y  (the effect being estimated)
 •  10 backdoor paths, one per confounder Xi:  T ← Xi → Y  (each is blocked by conditioning on Xi in the propensity-score model)</a:t>
             </a:r>
@@ -4934,7 +4934,7 @@
                 </a:solidFill>
                 <a:latin typeface="Calibri"/>
               </a:rPr>
-              <a:t>Minimal sufficient adjustment set, Z (10 variables): {Maternal age, Race/ethnicity, Education, Prenatal-care timing, WIC participation, Parity, Prior preterm birth, Pre-pregnancy diabetes, Pre-pregnancy hypertension, Pre-pregnancy BMI}. Sufficient: conditioning on Z blocks all 10 backdoor paths above (each Xi sits on exactly one). Minimal: no Xi can be dropped from Z, since each is the only node on its own backdoor path — dropping it leaves that path unblocked; and Z contains no mediator or collider of T → Y, so nothing in Z should be dropped for that reason either.</a:t>
+              <a:t>Minimal sufficient adjustment set, Z (10 variables): {Maternal age, Race/ethnicity, Education, Prenatal-care timing, WIC participation, Parity, Prior preterm birth, Pre-pregnancy diabetes, Pre-pregnancy hypertension, Pre-pregnancy BMI}. Sufficient: conditioning on Z blocks all 10 backdoor paths above (each Xi sits on exactly one). Minimal: no Xi can be dropped from Z, since each is the only node on its own backdoor path, so dropping it leaves that path unblocked; and Z contains no mediator or collider of T → Y, so nothing in Z should be dropped for that reason either.</a:t>
             </a:r>
           </a:p>
         </p:txBody>
@@ -4969,7 +4969,7 @@
                 </a:solidFill>
                 <a:latin typeface="Calibri"/>
               </a:rPr>
-              <a:t>Each edge into T above was individually defended (not defaulted): a node is a parent of T only if it plausibly influences smoking behavior itself, not merely the outcome. Insurance/payer type was considered and excluded on exactly this test — see the proposal text for the full node-by-node defense, including why it is still discussed despite its empirical correlation with smoking. A second, supplementary diagram (next slide) shows an assumed ordering AMONG the confounders themselves; see its note for why those additional indirect paths do not require separate treatment.</a:t>
+              <a:t>Each edge into T above was individually defended (not defaulted): a node is a parent of T only if it plausibly influences smoking behavior itself, not merely the outcome. Insurance/payer type was considered and excluded on exactly this test; see the proposal text for the full node-by-node defense, including why it is still discussed despite its empirical correlation with smoking. A second, supplementary diagram (next slide) shows an assumed ordering among the confounders themselves; see its note for why those additional indirect paths do not require separate treatment.</a:t>
             </a:r>
           </a:p>
         </p:txBody>
@@ -6372,23 +6372,44 @@
           </a:p>
         </p:txBody>
       </p:sp>
-      <p:cxnSp>
-        <p:nvCxnSpPr>
-          <p:cNvPr id="22" name="Connector 21"/>
-          <p:cNvCxnSpPr>
-            <a:stCxn id="5" idx="2"/>
-            <a:endCxn id="21" idx="3"/>
-          </p:cNvCxnSpPr>
+      <p:sp>
+        <p:nvSpPr>
+          <p:cNvPr id="22" name="Freeform 21"/>
+          <p:cNvSpPr/>
           <p:nvPr/>
-        </p:nvCxnSpPr>
-        <p:spPr>
-          <a:xfrm>
-            <a:off x="4937759" y="3703320"/>
-            <a:ext cx="15910561" cy="5280660"/>
-          </a:xfrm>
-          <a:prstGeom prst="bentConnector3">
-            <a:avLst/>
-          </a:prstGeom>
+        </p:nvSpPr>
+        <p:spPr>
+          <a:xfrm>
+            <a:off x="6309359" y="3223260"/>
+            <a:ext cx="11612881" cy="5760720"/>
+          </a:xfrm>
+          <a:custGeom>
+            <a:avLst/>
+            <a:gdLst/>
+            <a:ahLst/>
+            <a:cxnLst/>
+            <a:rect l="l" t="t" r="r" b="b"/>
+            <a:pathLst>
+              <a:path w="11612881" h="5760720">
+                <a:moveTo>
+                  <a:pt x="0" y="0"/>
+                </a:moveTo>
+                <a:lnTo>
+                  <a:pt x="0" y="891540"/>
+                </a:lnTo>
+                <a:lnTo>
+                  <a:pt x="10607041" y="891540"/>
+                </a:lnTo>
+                <a:lnTo>
+                  <a:pt x="10607041" y="5760720"/>
+                </a:lnTo>
+                <a:lnTo>
+                  <a:pt x="11612881" y="5760720"/>
+                </a:lnTo>
+              </a:path>
+            </a:pathLst>
+          </a:custGeom>
+          <a:noFill/>
           <a:ln w="34925">
             <a:solidFill>
               <a:srgbClr val="C1611A"/>
@@ -6398,20 +6419,27 @@
           <a:effectLst/>
         </p:spPr>
         <p:style>
-          <a:lnRef idx="2">
+          <a:lnRef idx="1">
             <a:schemeClr val="accent1"/>
           </a:lnRef>
-          <a:fillRef idx="0">
+          <a:fillRef idx="3">
             <a:schemeClr val="accent1"/>
           </a:fillRef>
-          <a:effectRef idx="1">
+          <a:effectRef idx="2">
             <a:schemeClr val="accent1"/>
           </a:effectRef>
           <a:fontRef idx="minor">
-            <a:schemeClr val="tx1"/>
+            <a:schemeClr val="lt1"/>
           </a:fontRef>
         </p:style>
-      </p:cxnSp>
+        <p:txBody>
+          <a:bodyPr rtlCol="0" anchor="ctr"/>
+          <a:lstStyle/>
+          <a:p>
+            <a:pPr algn="ctr"/>
+          </a:p>
+        </p:txBody>
+      </p:sp>
       <p:sp>
         <p:nvSpPr>
           <p:cNvPr id="23" name="TextBox 22"/>
@@ -6442,8 +6470,8 @@
                 </a:solidFill>
                 <a:latin typeface="Calibri"/>
               </a:rPr>
-              <a:t>Note. These steel-blue dashed arrows reflect an assumed temporal / conceptual ordering standard in the perinatal-epidemiology literature (e.g., sociodemographic factors treated as upstream of clinical risk factors) — they are NOT associations estimated from this dataset, and this diagram is not needed to justify the adjustment set. Why: every confounder here is still a direct parent of both T and Y (previous slide), so conditioning on each one individually blocks every path that passes through it, including any longer indirect path that runs through this ordering (a standard d-separation result: conditioning on a non-collider blocks every path through that node). No separate accounting of these indirect paths is required.
-The solid orange arrow (Education → T) is the one edge into exposure drawn on this slide, shown here deliberately per Dr. Ghosh's feedback: education is the confounder whose edge into smoking is most directly defended in the proposal text, and showing it alongside the assumed ordering makes clear that this diagram's edges are not purely among confounders — one of them terminates in exposure itself. It does not add a 12th path: T ← Education → Y is already path (2) on slide 1.</a:t>
+              <a:t>Note. These steel-blue dashed arrows reflect an assumed temporal / conceptual ordering standard in the perinatal-epidemiology literature (e.g., sociodemographic factors treated as upstream of clinical risk factors); they are not associations estimated from this dataset, and this diagram is not needed to justify the adjustment set. Every confounder here is still a direct parent of both T and Y (previous slide), so conditioning on each one individually blocks every path that passes through it, including any longer indirect path that runs through this ordering (a standard d-separation result: conditioning on a non-collider blocks every path through that node). No separate accounting of these indirect paths is required.
+The solid orange arrow (Education → T) is the one edge into exposure drawn on this slide, shown here deliberately: education is the confounder whose edge into smoking is most directly defended in the proposal text, and showing it alongside the assumed ordering makes clear that this diagram's edges are not purely among confounders; one of them terminates in exposure itself. It does not add a twelfth path: T ← Education → Y is already path (2) on slide 1.</a:t>
             </a:r>
           </a:p>
         </p:txBody>

</xml_diff>